<commit_message>
polish(seg3-slides): 排版美化 — metadata 章節號重編 + 左卡補白 + s4/s6 區隔 + maxIter 7→5
1. metadata 章節號重編成乾淨 4 段(原本重複+跳號):
   00 AGENDA / 01·①② 為什麼 / 02·①~⑦ 怎麼運作 / 03 Live Demo / 04·① 收尾
   (修掉 ①②③ 各重複一次、01→03→05 跳號)
2. s11 maxIter 左卡補「情境」兩行,跟右卡平衡(原本左疏右密)
3. s4 改成抽象「4 步骨架」(呼叫第一個工具/看結果決定下一個),
   把具體 search_courses→arxiv trace 讓給 s6,消除兩張重複感
4. maxIterations 7 → 5(對齊 mini-project 的新預設):
   loop_diagram 副標、max_iter 標題與內文

註:檔案有重複的廢 build_messages_growth(line 287,被 481 覆蓋),
A2-cut 殘留,不影響輸出,暫不處理。
</commit_message>
<xml_diff>
--- a/slides/03-agentic-tool-loop.pptx
+++ b/slides/03-agentic-tool-loop.pptx
@@ -3615,7 +3615,7 @@
                 </a:solidFill>
                 <a:latin typeface="Calibri"/>
               </a:rPr>
-              <a:t>01 · ⑤   A G E N T   =   2 0   行 迴 圈</a:t>
+              <a:t>02 · ⑥   A G E N T   =   2 0   行 迴 圈</a:t>
             </a:r>
           </a:p>
         </p:txBody>
@@ -4234,7 +4234,7 @@
                 </a:solidFill>
                 <a:latin typeface="Calibri"/>
               </a:rPr>
-              <a:t>03 · ①   M A X _ I T E R A T I O N S · 強制回覆</a:t>
+              <a:t>02 · ⑦   M A X _ I T E R A T I O N S · 強制回覆</a:t>
             </a:r>
           </a:p>
         </p:txBody>
@@ -4464,17 +4464,49 @@
           <a:p>
             <a:pPr algn="l">
               <a:spcAft>
+                <a:spcPts val="1350"/>
+              </a:spcAft>
+            </a:pPr>
+            <a:r>
+              <a:rPr sz="1050" b="0" i="0">
+                <a:solidFill>
+                  <a:srgbClr val="B91C1C"/>
+                </a:solidFill>
+                <a:latin typeface="Calibri"/>
+              </a:rPr>
+              <a:t>✗  使用者體驗極差</a:t>
+            </a:r>
+          </a:p>
+          <a:p>
+            <a:pPr algn="l">
+              <a:spcAft>
+                <a:spcPts val="150"/>
+              </a:spcAft>
+            </a:pPr>
+            <a:r>
+              <a:rPr sz="975" b="0" i="1">
+                <a:solidFill>
+                  <a:srgbClr val="374151"/>
+                </a:solidFill>
+                <a:latin typeface="Calibri"/>
+              </a:rPr>
+              <a:t>情境:LLM 一直查課 → 查老師 → 查論文 →</a:t>
+            </a:r>
+          </a:p>
+          <a:p>
+            <a:pPr algn="l">
+              <a:spcAft>
                 <a:spcPts val="0"/>
               </a:spcAft>
             </a:pPr>
             <a:r>
-              <a:rPr sz="1050" b="0" i="0">
-                <a:solidFill>
-                  <a:srgbClr val="B91C1C"/>
+              <a:rPr sz="975" b="0" i="1">
+                <a:solidFill>
+                  <a:srgbClr val="374151"/>
                 </a:solidFill>
                 <a:latin typeface="Calibri"/>
               </a:rPr>
-              <a:t>✗  使用者體驗極差</a:t>
+              <a:t>再查… 30 秒過去,使用者還沒等到任何回答。</a:t>
             </a:r>
           </a:p>
         </p:txBody>
@@ -4557,7 +4589,7 @@
                 </a:solidFill>
                 <a:latin typeface="Arial Black"/>
               </a:rPr>
-              <a:t>解法:maxIterations = 7</a:t>
+              <a:t>解法:maxIterations = 5</a:t>
             </a:r>
           </a:p>
         </p:txBody>
@@ -4612,7 +4644,7 @@
                 </a:solidFill>
                 <a:latin typeface="Calibri"/>
               </a:rPr>
-              <a:t>✓  第 7 輪(最後一輪)時注入臨時</a:t>
+              <a:t>✓  第 5 輪(最後一輪)時注入臨時</a:t>
             </a:r>
           </a:p>
           <a:p>
@@ -4851,7 +4883,7 @@
                 </a:solidFill>
                 <a:latin typeface="Calibri"/>
               </a:rPr>
-              <a:t>04   L I V E   D E M O</a:t>
+              <a:t>03   L I V E   D E M O</a:t>
             </a:r>
           </a:p>
         </p:txBody>
@@ -6246,7 +6278,7 @@
                 </a:solidFill>
                 <a:latin typeface="Calibri"/>
               </a:rPr>
-              <a:t>05 · ①   S T R A T E G I E S · 回看</a:t>
+              <a:t>04 · ①   S T R A T E G I E S · 回看</a:t>
             </a:r>
           </a:p>
         </p:txBody>
@@ -8938,7 +8970,7 @@
                 </a:solidFill>
                 <a:latin typeface="Calibri"/>
               </a:rPr>
-              <a:t>01 · ③   A G E N T I C · 解法預覽</a:t>
+              <a:t>01 · ②   A G E N T I C · 解法預覽</a:t>
             </a:r>
           </a:p>
         </p:txBody>
@@ -8973,7 +9005,7 @@
                 </a:solidFill>
                 <a:latin typeface="Arial Black"/>
               </a:rPr>
-              <a:t>Agentic 怎麼解 — 一個 query 的 4 步走法</a:t>
+              <a:t>Agentic 怎麼解 — 4 步走法的骨架</a:t>
             </a:r>
           </a:p>
         </p:txBody>
@@ -9008,7 +9040,7 @@
                 </a:solidFill>
                 <a:latin typeface="Calibri"/>
               </a:rPr>
-              <a:t>範例:"找 AI 課程 + 看這些老師最近的論文"</a:t>
+              <a:t>不管什麼複合問題,都是這 4 步;具體走一遍見下一頁</a:t>
             </a:r>
           </a:p>
         </p:txBody>
@@ -9206,8 +9238,8 @@
                 <a:latin typeface="Calibri"/>
               </a:rPr>
               <a:t>LLM 看問題 →
-想到要做兩件事:
-找課程 + 找論文</a:t>
+拆成幾個子任務
+(自己想,你沒教)</a:t>
             </a:r>
           </a:p>
         </p:txBody>
@@ -9439,9 +9471,8 @@
                 </a:solidFill>
                 <a:latin typeface="Calibri"/>
               </a:rPr>
-              <a:t>search_courses
-  (keyword='AI')
-→ 拿到 5 門課</a:t>
+              <a:t>呼叫第一個工具
+→ 拿到中間結果</a:t>
             </a:r>
           </a:p>
         </p:txBody>
@@ -9638,7 +9669,7 @@
                 </a:solidFill>
                 <a:latin typeface="Arial Black"/>
               </a:rPr>
-              <a:t>第二輪 tool call</a:t>
+              <a:t>下一輪 tool call</a:t>
             </a:r>
           </a:p>
         </p:txBody>
@@ -9673,9 +9704,9 @@
                 </a:solidFill>
                 <a:latin typeface="Calibri"/>
               </a:rPr>
-              <a:t>看到課的老師後:
-for each 老師 →
-arxiv_search (parallel)</a:t>
+              <a:t>看上一輪結果
+→ 決定下一個工具
+(可多個並行)</a:t>
             </a:r>
           </a:p>
         </p:txBody>
@@ -10118,7 +10149,7 @@
                 </a:solidFill>
                 <a:latin typeface="Calibri"/>
               </a:rPr>
-              <a:t>01 · ①   A G E N T I C   L O O P · 概念圖</a:t>
+              <a:t>02 · ①   A G E N T I C   L O O P · 概念圖</a:t>
             </a:r>
           </a:p>
         </p:txBody>
@@ -10188,7 +10219,7 @@
                 </a:solidFill>
                 <a:latin typeface="Calibri"/>
               </a:rPr>
-              <a:t>每一輪稱為一個 iteration,最多 maxIterations(預設 7)輪</a:t>
+              <a:t>每一輪稱為一個 iteration,最多 maxIterations(預設 5)輪</a:t>
             </a:r>
           </a:p>
         </p:txBody>
@@ -11194,7 +11225,7 @@
                 </a:solidFill>
                 <a:latin typeface="Calibri"/>
               </a:rPr>
-              <a:t>01 · ②   A G E N T I C   L O O P · 實 例 走 查</a:t>
+              <a:t>02 · ②   A G E N T I C   L O O P · 實 例 走 查</a:t>
             </a:r>
           </a:p>
         </p:txBody>
@@ -12125,7 +12156,7 @@
                 </a:solidFill>
                 <a:latin typeface="Calibri"/>
               </a:rPr>
-              <a:t>01 · ②   T O O L _ U S E   /   T O O L _ R E S U L T</a:t>
+              <a:t>02 · ③   T O O L _ U S E   /   T O O L _ R E S U L T</a:t>
             </a:r>
           </a:p>
         </p:txBody>
@@ -12737,7 +12768,7 @@
                 </a:solidFill>
                 <a:latin typeface="Calibri"/>
               </a:rPr>
-              <a:t>01 · ③   M E S S A G E S   陣 列</a:t>
+              <a:t>02 · ④   M E S S A G E S   陣 列</a:t>
             </a:r>
           </a:p>
         </p:txBody>
@@ -13983,7 +14014,7 @@
                 </a:solidFill>
                 <a:latin typeface="Calibri"/>
               </a:rPr>
-              <a:t>01 · ④   P A R A L L E L   T O O L   C A L L S</a:t>
+              <a:t>02 · ⑤   P A R A L L E L   T O O L   C A L L S</a:t>
             </a:r>
           </a:p>
         </p:txBody>

</xml_diff>